<commit_message>
Give the slide numbers room; two-digit numbers were wrapping
The box was 0.30" wide, but textbox() defaults to word_wrap=True and python-pptx adds
0.1" side margins -- leaving roughly 0.10" of usable width. Enough for one digit, so
every number from 10 up broke onto two lines.

Three fixes, because any one alone would have been fragile:
  * widened to 0.35" (the right-hand gutter is 0.43", so this still clears content)
  * zeroed the text-frame margins, which were consuming two thirds of the box
  * set word_wrap = False, so a page number can never wrap whatever its width

Verified by rendering and cropping the corner on slide 16 and on slide 12 -- a
two-digit number beside content that runs out to x=12.85 -- rather than only checking
the geometry, plus a programmatic pass confirming all 16 stamps are present, non-wrapping
and free of overlap.

Co-Authored-By: Claude Opus 5 (1M context) <noreply@anthropic.com>
</commit_message>
<xml_diff>
--- a/docs/AutoBench.pptx
+++ b/docs/AutoBench.pptx
@@ -3358,7 +3358,7 @@
                 </a:solidFill>
                 <a:latin typeface="Calibri"/>
               </a:rPr>
-              <a:t>Last modified 2026-09-09 14:47 EDT</a:t>
+              <a:t>Last modified 2026-09-09 14:53 EDT</a:t>
             </a:r>
           </a:p>
         </p:txBody>
@@ -3371,8 +3371,8 @@
         </p:nvSpPr>
         <p:spPr>
           <a:xfrm>
-            <a:off x="11841480" y="6455664"/>
-            <a:ext cx="274320" cy="274320"/>
+            <a:off x="11795760" y="6437376"/>
+            <a:ext cx="320040" cy="310896"/>
           </a:xfrm>
           <a:prstGeom prst="rect">
             <a:avLst/>
@@ -3380,7 +3380,7 @@
           <a:noFill/>
         </p:spPr>
         <p:txBody>
-          <a:bodyPr wrap="square" anchor="ctr">
+          <a:bodyPr wrap="none" anchor="ctr" lIns="0" rIns="0" tIns="0" bIns="0">
             <a:spAutoFit/>
           </a:bodyPr>
           <a:lstStyle/>
@@ -4505,8 +4505,8 @@
         </p:nvSpPr>
         <p:spPr>
           <a:xfrm>
-            <a:off x="11841480" y="6455664"/>
-            <a:ext cx="274320" cy="274320"/>
+            <a:off x="11795760" y="6437376"/>
+            <a:ext cx="320040" cy="310896"/>
           </a:xfrm>
           <a:prstGeom prst="rect">
             <a:avLst/>
@@ -4514,7 +4514,7 @@
           <a:noFill/>
         </p:spPr>
         <p:txBody>
-          <a:bodyPr wrap="square" anchor="ctr">
+          <a:bodyPr wrap="none" anchor="ctr" lIns="0" rIns="0" tIns="0" bIns="0">
             <a:spAutoFit/>
           </a:bodyPr>
           <a:lstStyle/>
@@ -4961,8 +4961,8 @@
         </p:nvSpPr>
         <p:spPr>
           <a:xfrm>
-            <a:off x="11841480" y="6455664"/>
-            <a:ext cx="274320" cy="274320"/>
+            <a:off x="11795760" y="6437376"/>
+            <a:ext cx="320040" cy="310896"/>
           </a:xfrm>
           <a:prstGeom prst="rect">
             <a:avLst/>
@@ -4970,7 +4970,7 @@
           <a:noFill/>
         </p:spPr>
         <p:txBody>
-          <a:bodyPr wrap="square" anchor="ctr">
+          <a:bodyPr wrap="none" anchor="ctr" lIns="0" rIns="0" tIns="0" bIns="0">
             <a:spAutoFit/>
           </a:bodyPr>
           <a:lstStyle/>
@@ -6687,8 +6687,8 @@
         </p:nvSpPr>
         <p:spPr>
           <a:xfrm>
-            <a:off x="11841480" y="6455664"/>
-            <a:ext cx="274320" cy="274320"/>
+            <a:off x="11795760" y="6437376"/>
+            <a:ext cx="320040" cy="310896"/>
           </a:xfrm>
           <a:prstGeom prst="rect">
             <a:avLst/>
@@ -6696,7 +6696,7 @@
           <a:noFill/>
         </p:spPr>
         <p:txBody>
-          <a:bodyPr wrap="square" anchor="ctr">
+          <a:bodyPr wrap="none" anchor="ctr" lIns="0" rIns="0" tIns="0" bIns="0">
             <a:spAutoFit/>
           </a:bodyPr>
           <a:lstStyle/>
@@ -8693,8 +8693,8 @@
         </p:nvSpPr>
         <p:spPr>
           <a:xfrm>
-            <a:off x="11841480" y="6455664"/>
-            <a:ext cx="274320" cy="274320"/>
+            <a:off x="11795760" y="6437376"/>
+            <a:ext cx="320040" cy="310896"/>
           </a:xfrm>
           <a:prstGeom prst="rect">
             <a:avLst/>
@@ -8702,7 +8702,7 @@
           <a:noFill/>
         </p:spPr>
         <p:txBody>
-          <a:bodyPr wrap="square" anchor="ctr">
+          <a:bodyPr wrap="none" anchor="ctr" lIns="0" rIns="0" tIns="0" bIns="0">
             <a:spAutoFit/>
           </a:bodyPr>
           <a:lstStyle/>
@@ -11299,8 +11299,8 @@
         </p:nvSpPr>
         <p:spPr>
           <a:xfrm>
-            <a:off x="11841480" y="6455664"/>
-            <a:ext cx="274320" cy="274320"/>
+            <a:off x="11795760" y="6437376"/>
+            <a:ext cx="320040" cy="310896"/>
           </a:xfrm>
           <a:prstGeom prst="rect">
             <a:avLst/>
@@ -11308,7 +11308,7 @@
           <a:noFill/>
         </p:spPr>
         <p:txBody>
-          <a:bodyPr wrap="square" anchor="ctr">
+          <a:bodyPr wrap="none" anchor="ctr" lIns="0" rIns="0" tIns="0" bIns="0">
             <a:spAutoFit/>
           </a:bodyPr>
           <a:lstStyle/>
@@ -12403,8 +12403,8 @@
         </p:nvSpPr>
         <p:spPr>
           <a:xfrm>
-            <a:off x="11841480" y="6455664"/>
-            <a:ext cx="274320" cy="274320"/>
+            <a:off x="11795760" y="6437376"/>
+            <a:ext cx="320040" cy="310896"/>
           </a:xfrm>
           <a:prstGeom prst="rect">
             <a:avLst/>
@@ -12412,7 +12412,7 @@
           <a:noFill/>
         </p:spPr>
         <p:txBody>
-          <a:bodyPr wrap="square" anchor="ctr">
+          <a:bodyPr wrap="none" anchor="ctr" lIns="0" rIns="0" tIns="0" bIns="0">
             <a:spAutoFit/>
           </a:bodyPr>
           <a:lstStyle/>
@@ -13007,8 +13007,8 @@
         </p:nvSpPr>
         <p:spPr>
           <a:xfrm>
-            <a:off x="11841480" y="6455664"/>
-            <a:ext cx="274320" cy="274320"/>
+            <a:off x="11795760" y="6437376"/>
+            <a:ext cx="320040" cy="310896"/>
           </a:xfrm>
           <a:prstGeom prst="rect">
             <a:avLst/>
@@ -13016,7 +13016,7 @@
           <a:noFill/>
         </p:spPr>
         <p:txBody>
-          <a:bodyPr wrap="square" anchor="ctr">
+          <a:bodyPr wrap="none" anchor="ctr" lIns="0" rIns="0" tIns="0" bIns="0">
             <a:spAutoFit/>
           </a:bodyPr>
           <a:lstStyle/>
@@ -14494,8 +14494,8 @@
         </p:nvSpPr>
         <p:spPr>
           <a:xfrm>
-            <a:off x="11841480" y="6455664"/>
-            <a:ext cx="274320" cy="274320"/>
+            <a:off x="11795760" y="6437376"/>
+            <a:ext cx="320040" cy="310896"/>
           </a:xfrm>
           <a:prstGeom prst="rect">
             <a:avLst/>
@@ -14503,7 +14503,7 @@
           <a:noFill/>
         </p:spPr>
         <p:txBody>
-          <a:bodyPr wrap="square" anchor="ctr">
+          <a:bodyPr wrap="none" anchor="ctr" lIns="0" rIns="0" tIns="0" bIns="0">
             <a:spAutoFit/>
           </a:bodyPr>
           <a:lstStyle/>
@@ -15414,8 +15414,8 @@
         </p:nvSpPr>
         <p:spPr>
           <a:xfrm>
-            <a:off x="11841480" y="6455664"/>
-            <a:ext cx="274320" cy="274320"/>
+            <a:off x="11795760" y="6437376"/>
+            <a:ext cx="320040" cy="310896"/>
           </a:xfrm>
           <a:prstGeom prst="rect">
             <a:avLst/>
@@ -15423,7 +15423,7 @@
           <a:noFill/>
         </p:spPr>
         <p:txBody>
-          <a:bodyPr wrap="square" anchor="ctr">
+          <a:bodyPr wrap="none" anchor="ctr" lIns="0" rIns="0" tIns="0" bIns="0">
             <a:spAutoFit/>
           </a:bodyPr>
           <a:lstStyle/>
@@ -17144,8 +17144,8 @@
         </p:nvSpPr>
         <p:spPr>
           <a:xfrm>
-            <a:off x="11841480" y="6455664"/>
-            <a:ext cx="274320" cy="274320"/>
+            <a:off x="11795760" y="6437376"/>
+            <a:ext cx="320040" cy="310896"/>
           </a:xfrm>
           <a:prstGeom prst="rect">
             <a:avLst/>
@@ -17153,7 +17153,7 @@
           <a:noFill/>
         </p:spPr>
         <p:txBody>
-          <a:bodyPr wrap="square" anchor="ctr">
+          <a:bodyPr wrap="none" anchor="ctr" lIns="0" rIns="0" tIns="0" bIns="0">
             <a:spAutoFit/>
           </a:bodyPr>
           <a:lstStyle/>
@@ -19549,8 +19549,8 @@
         </p:nvSpPr>
         <p:spPr>
           <a:xfrm>
-            <a:off x="11841480" y="6455664"/>
-            <a:ext cx="274320" cy="274320"/>
+            <a:off x="11795760" y="6437376"/>
+            <a:ext cx="320040" cy="310896"/>
           </a:xfrm>
           <a:prstGeom prst="rect">
             <a:avLst/>
@@ -19558,7 +19558,7 @@
           <a:noFill/>
         </p:spPr>
         <p:txBody>
-          <a:bodyPr wrap="square" anchor="ctr">
+          <a:bodyPr wrap="none" anchor="ctr" lIns="0" rIns="0" tIns="0" bIns="0">
             <a:spAutoFit/>
           </a:bodyPr>
           <a:lstStyle/>
@@ -22293,8 +22293,8 @@
         </p:nvSpPr>
         <p:spPr>
           <a:xfrm>
-            <a:off x="11841480" y="6455664"/>
-            <a:ext cx="274320" cy="274320"/>
+            <a:off x="11795760" y="6437376"/>
+            <a:ext cx="320040" cy="310896"/>
           </a:xfrm>
           <a:prstGeom prst="rect">
             <a:avLst/>
@@ -22302,7 +22302,7 @@
           <a:noFill/>
         </p:spPr>
         <p:txBody>
-          <a:bodyPr wrap="square" anchor="ctr">
+          <a:bodyPr wrap="none" anchor="ctr" lIns="0" rIns="0" tIns="0" bIns="0">
             <a:spAutoFit/>
           </a:bodyPr>
           <a:lstStyle/>
@@ -22833,8 +22833,8 @@
         </p:nvSpPr>
         <p:spPr>
           <a:xfrm>
-            <a:off x="11841480" y="6455664"/>
-            <a:ext cx="274320" cy="274320"/>
+            <a:off x="11795760" y="6437376"/>
+            <a:ext cx="320040" cy="310896"/>
           </a:xfrm>
           <a:prstGeom prst="rect">
             <a:avLst/>
@@ -22842,7 +22842,7 @@
           <a:noFill/>
         </p:spPr>
         <p:txBody>
-          <a:bodyPr wrap="square" anchor="ctr">
+          <a:bodyPr wrap="none" anchor="ctr" lIns="0" rIns="0" tIns="0" bIns="0">
             <a:spAutoFit/>
           </a:bodyPr>
           <a:lstStyle/>
@@ -23873,8 +23873,8 @@
         </p:nvSpPr>
         <p:spPr>
           <a:xfrm>
-            <a:off x="11841480" y="6455664"/>
-            <a:ext cx="274320" cy="274320"/>
+            <a:off x="11795760" y="6437376"/>
+            <a:ext cx="320040" cy="310896"/>
           </a:xfrm>
           <a:prstGeom prst="rect">
             <a:avLst/>
@@ -23882,7 +23882,7 @@
           <a:noFill/>
         </p:spPr>
         <p:txBody>
-          <a:bodyPr wrap="square" anchor="ctr">
+          <a:bodyPr wrap="none" anchor="ctr" lIns="0" rIns="0" tIns="0" bIns="0">
             <a:spAutoFit/>
           </a:bodyPr>
           <a:lstStyle/>
@@ -25205,8 +25205,8 @@
         </p:nvSpPr>
         <p:spPr>
           <a:xfrm>
-            <a:off x="11841480" y="6455664"/>
-            <a:ext cx="274320" cy="274320"/>
+            <a:off x="11795760" y="6437376"/>
+            <a:ext cx="320040" cy="310896"/>
           </a:xfrm>
           <a:prstGeom prst="rect">
             <a:avLst/>
@@ -25214,7 +25214,7 @@
           <a:noFill/>
         </p:spPr>
         <p:txBody>
-          <a:bodyPr wrap="square" anchor="ctr">
+          <a:bodyPr wrap="none" anchor="ctr" lIns="0" rIns="0" tIns="0" bIns="0">
             <a:spAutoFit/>
           </a:bodyPr>
           <a:lstStyle/>

</xml_diff>

<commit_message>
Retitle slide 3: "Implementation Architecture: Kubernetes-Based Benchmark Workloads"
"3. Architecture" said nothing about what the slide shows. The new title
names the subject — how the benchmark workloads are laid out on Kubernetes —
and, because the deck's PDF bookmarks are generated from each slide's title
text, it now reads usefully in the outline too.

Verified: the 68-char title still renders on one line inside the navy band
at 26pt and clears both the diagram and the page number.

Co-Authored-By: Claude Opus 5 <noreply@anthropic.com>
</commit_message>
<xml_diff>
--- a/docs/AutoBench.pptx
+++ b/docs/AutoBench.pptx
@@ -3358,7 +3358,7 @@
                 </a:solidFill>
                 <a:latin typeface="Calibri"/>
               </a:rPr>
-              <a:t>Last modified 2026-09-11 21:53 EDT</a:t>
+              <a:t>Last modified 2026-09-11 22:06 EDT</a:t>
             </a:r>
           </a:p>
         </p:txBody>
@@ -17350,7 +17350,7 @@
 
 <file path=ppt/slides/slide5.xml><?xml version="1.0" encoding="utf-8"?>
 <p:sld xmlns:a="http://schemas.openxmlformats.org/drawingml/2006/main" xmlns:p="http://schemas.openxmlformats.org/presentationml/2006/main" xmlns:r="http://schemas.openxmlformats.org/officeDocument/2006/relationships">
-  <p:cSld name="3. Architecture">
+  <p:cSld name="3. Implementation Architecture: Kubernetes-Based Benchmark Workloads">
     <p:spTree>
       <p:nvGrpSpPr>
         <p:cNvPr id="1" name=""/>
@@ -17406,7 +17406,7 @@
                 </a:solidFill>
                 <a:latin typeface="Calibri"/>
               </a:rPr>
-              <a:t>3.  Architecture</a:t>
+              <a:t>3.  Implementation Architecture: Kubernetes-Based Benchmark Workloads</a:t>
             </a:r>
           </a:p>
           <a:p>

</xml_diff>